<commit_message>
finilized the fastapi wrapper
</commit_message>
<xml_diff>
--- a/data/tenders/69cfa03fc5f143e47a75fde7/documents/doc_003.pptx
+++ b/data/tenders/69cfa03fc5f143e47a75fde7/documents/doc_003.pptx
@@ -310,7 +310,7 @@
               </a:lnSpc>
               <a:buNone/>
             </a:pPr>
-            <a:fld id="{13E0340D-1459-49EF-80F0-03060410EE83}" type="slidenum">
+            <a:fld id="{A9B92719-34FE-4B33-A981-D93066B0F515}" type="slidenum">
               <a:rPr lang="ru-RU" sz="1400" b="0" u="none" strike="noStrike">
                 <a:solidFill>
                   <a:srgbClr val="000000"/>
@@ -385,7 +385,7 @@
                 <a:spcPct val="100000"/>
               </a:lnSpc>
             </a:pPr>
-            <a:fld id="{BFFCF617-A13A-448E-AD26-3D7D9820ACFA}" type="slidenum">
+            <a:fld id="{34B409A8-0147-49FE-B5E2-58A2C45E06CC}" type="slidenum">
               <a:rPr lang="ru-RU" sz="1400" b="0" u="none" strike="noStrike">
                 <a:solidFill>
                   <a:srgbClr val="000000"/>
@@ -437,7 +437,7 @@
                 <a:spcPct val="100000"/>
               </a:lnSpc>
             </a:pPr>
-            <a:fld id="{F27A27E8-DEFB-4DCE-90C0-D760D13916D9}" type="slidenum">
+            <a:fld id="{7FE9F3DF-4E19-401A-96F1-1533FA35CBA7}" type="slidenum">
               <a:rPr lang="ru-RU" sz="1400" b="0" u="none" strike="noStrike">
                 <a:solidFill>
                   <a:srgbClr val="000000"/>
@@ -489,7 +489,7 @@
                 <a:spcPct val="100000"/>
               </a:lnSpc>
             </a:pPr>
-            <a:fld id="{9E594113-8CD2-4084-A570-308482F662E4}" type="slidenum">
+            <a:fld id="{C6EBF0B8-AB96-403C-848E-6E1B41D980C3}" type="slidenum">
               <a:rPr lang="ru-RU" sz="1400" b="0" u="none" strike="noStrike">
                 <a:solidFill>
                   <a:srgbClr val="000000"/>
@@ -541,7 +541,7 @@
                 <a:spcPct val="100000"/>
               </a:lnSpc>
             </a:pPr>
-            <a:fld id="{1E3CD0A7-654D-4FFD-AE67-540E337160A9}" type="slidenum">
+            <a:fld id="{05CD81E2-ADC1-4FFC-A860-3B074D661AF4}" type="slidenum">
               <a:rPr lang="ru-RU" sz="1400" b="0" u="none" strike="noStrike">
                 <a:solidFill>
                   <a:srgbClr val="000000"/>
@@ -593,7 +593,7 @@
                 <a:spcPct val="100000"/>
               </a:lnSpc>
             </a:pPr>
-            <a:fld id="{E4970F2E-D0EF-4646-B03F-587ACF406B05}" type="slidenum">
+            <a:fld id="{3E51FA50-32FF-4DB6-B0B2-4AA9BCB35024}" type="slidenum">
               <a:rPr lang="ru-RU" sz="1400" b="0" u="none" strike="noStrike">
                 <a:solidFill>
                   <a:srgbClr val="000000"/>
@@ -645,7 +645,7 @@
                 <a:spcPct val="100000"/>
               </a:lnSpc>
             </a:pPr>
-            <a:fld id="{0EA5B943-8CD3-41DE-B6AA-D9A245E486A8}" type="slidenum">
+            <a:fld id="{840385A9-C54B-4018-A55D-3F9F3832BE43}" type="slidenum">
               <a:rPr lang="ru-RU" sz="1400" b="0" u="none" strike="noStrike">
                 <a:solidFill>
                   <a:srgbClr val="000000"/>
@@ -784,7 +784,7 @@
                 <a:spcPct val="100000"/>
               </a:lnSpc>
             </a:pPr>
-            <a:fld id="{1BE38F83-9C16-4F19-8278-3E4BB372B0E5}" type="slidenum">
+            <a:fld id="{672E1D18-A861-4FD4-944E-BA79F9786797}" type="slidenum">
               <a:rPr lang="ru-RU" sz="1400" b="0" u="none" strike="noStrike">
                 <a:solidFill>
                   <a:srgbClr val="000000"/>
@@ -836,7 +836,7 @@
                 <a:spcPct val="100000"/>
               </a:lnSpc>
             </a:pPr>
-            <a:fld id="{C6F39228-88B6-4839-807E-54832150BE6D}" type="slidenum">
+            <a:fld id="{78A781B2-9706-4295-8F7B-1F99CFF4FC15}" type="slidenum">
               <a:rPr lang="ru-RU" sz="1400" b="0" u="none" strike="noStrike">
                 <a:solidFill>
                   <a:srgbClr val="000000"/>
@@ -888,7 +888,7 @@
                 <a:spcPct val="100000"/>
               </a:lnSpc>
             </a:pPr>
-            <a:fld id="{16DFC5D7-EC9B-45CA-9696-FBB65A223395}" type="slidenum">
+            <a:fld id="{E50939B5-77BD-4360-9AD4-45BA2E917408}" type="slidenum">
               <a:rPr lang="ru-RU" sz="1400" b="0" u="none" strike="noStrike">
                 <a:solidFill>
                   <a:srgbClr val="000000"/>
@@ -940,7 +940,7 @@
                 <a:spcPct val="100000"/>
               </a:lnSpc>
             </a:pPr>
-            <a:fld id="{A293B289-6600-438B-96A8-476AFA012A02}" type="slidenum">
+            <a:fld id="{88AF9FF0-5705-48FF-B19B-B1A41352EC04}" type="slidenum">
               <a:rPr lang="ru-RU" sz="1400" b="0" u="none" strike="noStrike">
                 <a:solidFill>
                   <a:srgbClr val="000000"/>
@@ -992,7 +992,7 @@
                 <a:spcPct val="100000"/>
               </a:lnSpc>
             </a:pPr>
-            <a:fld id="{F0DDBB18-E8C4-44B5-8826-FE93D10CC9C4}" type="slidenum">
+            <a:fld id="{342411E8-8485-44EB-8D78-F530B9E97DE9}" type="slidenum">
               <a:rPr lang="ru-RU" sz="1400" b="0" u="none" strike="noStrike">
                 <a:solidFill>
                   <a:srgbClr val="000000"/>
@@ -1044,7 +1044,7 @@
                 <a:spcPct val="100000"/>
               </a:lnSpc>
             </a:pPr>
-            <a:fld id="{492719F1-481C-417B-A957-A7E8B9ED2592}" type="slidenum">
+            <a:fld id="{299B86F5-1FDA-4993-B7E1-D95F89D7C007}" type="slidenum">
               <a:rPr lang="ru-RU" sz="1400" b="0" u="none" strike="noStrike">
                 <a:solidFill>
                   <a:srgbClr val="000000"/>
@@ -1183,7 +1183,7 @@
                 <a:spcPct val="100000"/>
               </a:lnSpc>
             </a:pPr>
-            <a:fld id="{432D2E3D-ED06-4615-B0E2-81AC2288601E}" type="slidenum">
+            <a:fld id="{BC5512AC-28DE-4415-A975-293686B58231}" type="slidenum">
               <a:rPr lang="ru-RU" sz="1400" b="0" u="none" strike="noStrike">
                 <a:solidFill>
                   <a:srgbClr val="000000"/>
@@ -1235,7 +1235,7 @@
                 <a:spcPct val="100000"/>
               </a:lnSpc>
             </a:pPr>
-            <a:fld id="{62633FD4-4667-4C46-AAFF-D1B75A4B1BE1}" type="slidenum">
+            <a:fld id="{68F64B2C-AE39-41CE-9B27-F5A9E444BAF1}" type="slidenum">
               <a:rPr lang="ru-RU" sz="1400" b="0" u="none" strike="noStrike">
                 <a:solidFill>
                   <a:srgbClr val="000000"/>
@@ -1287,7 +1287,7 @@
                 <a:spcPct val="100000"/>
               </a:lnSpc>
             </a:pPr>
-            <a:fld id="{BEDC00A7-A7C0-4C83-94FE-73C32973F918}" type="slidenum">
+            <a:fld id="{2915CC5F-48A2-4FCF-94DE-F9D723FF82EA}" type="slidenum">
               <a:rPr lang="ru-RU" sz="1400" b="0" u="none" strike="noStrike">
                 <a:solidFill>
                   <a:srgbClr val="000000"/>
@@ -1339,7 +1339,7 @@
                 <a:spcPct val="100000"/>
               </a:lnSpc>
             </a:pPr>
-            <a:fld id="{7BE62E61-6929-4B8E-BE8E-D2958CE55369}" type="slidenum">
+            <a:fld id="{F3BB68D3-0AD2-4099-ACF3-C14DC37D169A}" type="slidenum">
               <a:rPr lang="ru-RU" sz="1400" b="0" u="none" strike="noStrike">
                 <a:solidFill>
                   <a:srgbClr val="000000"/>
@@ -1391,7 +1391,7 @@
                 <a:spcPct val="100000"/>
               </a:lnSpc>
             </a:pPr>
-            <a:fld id="{7110432F-32E0-4D84-B869-ACB96053325A}" type="slidenum">
+            <a:fld id="{FE572B6A-D643-4838-A347-9A960D928752}" type="slidenum">
               <a:rPr lang="ru-RU" sz="1400" b="0" u="none" strike="noStrike">
                 <a:solidFill>
                   <a:srgbClr val="000000"/>
@@ -1443,7 +1443,7 @@
                 <a:spcPct val="100000"/>
               </a:lnSpc>
             </a:pPr>
-            <a:fld id="{A3B22202-9DD0-4885-BA69-6760D10A5767}" type="slidenum">
+            <a:fld id="{347B4587-8978-4515-ABB8-FF00AC39263A}" type="slidenum">
               <a:rPr lang="ru-RU" sz="1400" b="0" u="none" strike="noStrike">
                 <a:solidFill>
                   <a:srgbClr val="000000"/>
@@ -1582,7 +1582,7 @@
                 <a:spcPct val="100000"/>
               </a:lnSpc>
             </a:pPr>
-            <a:fld id="{36ED90DD-3B6B-499D-B2AE-774C815712F7}" type="slidenum">
+            <a:fld id="{29A3FC93-4C36-4B3D-ABBE-C8453F56BF8A}" type="slidenum">
               <a:rPr lang="ru-RU" sz="1400" b="0" u="none" strike="noStrike">
                 <a:solidFill>
                   <a:srgbClr val="000000"/>
@@ -1634,7 +1634,7 @@
                 <a:spcPct val="100000"/>
               </a:lnSpc>
             </a:pPr>
-            <a:fld id="{E849FFDD-66FE-487D-A69F-D9445C08D7E2}" type="slidenum">
+            <a:fld id="{DF2B953B-2934-43C0-B511-077A4112ACF7}" type="slidenum">
               <a:rPr lang="ru-RU" sz="1400" b="0" u="none" strike="noStrike">
                 <a:solidFill>
                   <a:srgbClr val="000000"/>
@@ -1686,7 +1686,7 @@
                 <a:spcPct val="100000"/>
               </a:lnSpc>
             </a:pPr>
-            <a:fld id="{3EE1C8C2-8996-4F66-8C30-EAE7ABF2F555}" type="slidenum">
+            <a:fld id="{1ACB5719-0EF6-47AD-862A-407970D5ACB4}" type="slidenum">
               <a:rPr lang="ru-RU" sz="1400" b="0" u="none" strike="noStrike">
                 <a:solidFill>
                   <a:srgbClr val="000000"/>
@@ -1738,7 +1738,7 @@
                 <a:spcPct val="100000"/>
               </a:lnSpc>
             </a:pPr>
-            <a:fld id="{FA19DAD8-7EED-4BD4-B5E8-9DE3CEB18071}" type="slidenum">
+            <a:fld id="{FD8EC2D1-33B6-4828-8BDD-51FF7C08E269}" type="slidenum">
               <a:rPr lang="ru-RU" sz="1400" b="0" u="none" strike="noStrike">
                 <a:solidFill>
                   <a:srgbClr val="000000"/>
@@ -1790,7 +1790,7 @@
                 <a:spcPct val="100000"/>
               </a:lnSpc>
             </a:pPr>
-            <a:fld id="{1750C616-F08C-4621-85C3-C9BAEA408281}" type="slidenum">
+            <a:fld id="{B8C000F1-8ADB-4204-A0C7-67C826B475F0}" type="slidenum">
               <a:rPr lang="ru-RU" sz="1400" b="0" u="none" strike="noStrike">
                 <a:solidFill>
                   <a:srgbClr val="000000"/>
@@ -1842,7 +1842,7 @@
                 <a:spcPct val="100000"/>
               </a:lnSpc>
             </a:pPr>
-            <a:fld id="{4A6C21CF-B629-4A68-B36D-949478295D1F}" type="slidenum">
+            <a:fld id="{D6114F43-297A-4617-AC48-57A5C78EC262}" type="slidenum">
               <a:rPr lang="ru-RU" sz="1400" b="0" u="none" strike="noStrike">
                 <a:solidFill>
                   <a:srgbClr val="000000"/>
@@ -1981,7 +1981,7 @@
                 <a:spcPct val="100000"/>
               </a:lnSpc>
             </a:pPr>
-            <a:fld id="{35AC6E64-5FF6-44AC-B628-82BCEE1E808C}" type="slidenum">
+            <a:fld id="{227F9DBB-FD89-4EE3-9296-2D00E3957E97}" type="slidenum">
               <a:rPr lang="ru-RU" sz="1400" b="0" u="none" strike="noStrike">
                 <a:solidFill>
                   <a:srgbClr val="000000"/>
@@ -2033,7 +2033,7 @@
                 <a:spcPct val="100000"/>
               </a:lnSpc>
             </a:pPr>
-            <a:fld id="{DDA12B9A-FFF2-40E9-AB05-80B90F5BEA1D}" type="slidenum">
+            <a:fld id="{0C71F89F-5BB5-4AD9-8804-5306CE42C15D}" type="slidenum">
               <a:rPr lang="ru-RU" sz="1400" b="0" u="none" strike="noStrike">
                 <a:solidFill>
                   <a:srgbClr val="000000"/>
@@ -2085,7 +2085,7 @@
                 <a:spcPct val="100000"/>
               </a:lnSpc>
             </a:pPr>
-            <a:fld id="{53D2BD02-1B3B-4B47-B317-9D966DB1AB20}" type="slidenum">
+            <a:fld id="{A16CFDA9-F8ED-4266-A659-7E8132A10882}" type="slidenum">
               <a:rPr lang="ru-RU" sz="1400" b="0" u="none" strike="noStrike">
                 <a:solidFill>
                   <a:srgbClr val="000000"/>
@@ -2137,7 +2137,7 @@
                 <a:spcPct val="100000"/>
               </a:lnSpc>
             </a:pPr>
-            <a:fld id="{571E55AA-BE3A-47B7-A3F8-36DC916BD713}" type="slidenum">
+            <a:fld id="{9709B2E4-DFF4-453B-ADAD-987BD02A3326}" type="slidenum">
               <a:rPr lang="ru-RU" sz="1400" b="0" u="none" strike="noStrike">
                 <a:solidFill>
                   <a:srgbClr val="000000"/>
@@ -2189,7 +2189,7 @@
                 <a:spcPct val="100000"/>
               </a:lnSpc>
             </a:pPr>
-            <a:fld id="{2F9FFAE1-9CA6-46E7-9876-0FD27489A7BF}" type="slidenum">
+            <a:fld id="{2F189CF7-459A-4EB9-9F6D-963C449D197A}" type="slidenum">
               <a:rPr lang="ru-RU" sz="1400" b="0" u="none" strike="noStrike">
                 <a:solidFill>
                   <a:srgbClr val="000000"/>
@@ -2241,7 +2241,7 @@
                 <a:spcPct val="100000"/>
               </a:lnSpc>
             </a:pPr>
-            <a:fld id="{DFA093BE-7732-4B0C-AE4B-94EEC468B77E}" type="slidenum">
+            <a:fld id="{2C232E66-51A9-4F67-B7E2-59A0BF81304A}" type="slidenum">
               <a:rPr lang="ru-RU" sz="1400" b="0" u="none" strike="noStrike">
                 <a:solidFill>
                   <a:srgbClr val="000000"/>
@@ -2380,7 +2380,7 @@
                 <a:spcPct val="100000"/>
               </a:lnSpc>
             </a:pPr>
-            <a:fld id="{C24AB3A8-C621-4DC5-900F-48B7E69E7F44}" type="slidenum">
+            <a:fld id="{23390F4D-4F33-4B01-B9ED-BC9E7655F111}" type="slidenum">
               <a:rPr lang="ru-RU" sz="1400" b="0" u="none" strike="noStrike">
                 <a:solidFill>
                   <a:srgbClr val="000000"/>
@@ -2432,7 +2432,7 @@
                 <a:spcPct val="100000"/>
               </a:lnSpc>
             </a:pPr>
-            <a:fld id="{D39C8220-BCEE-429D-915E-FCF306DEDC02}" type="slidenum">
+            <a:fld id="{9CF34183-F2EA-4F0A-AE7C-81CF8FD5DB96}" type="slidenum">
               <a:rPr lang="ru-RU" sz="1400" b="0" u="none" strike="noStrike">
                 <a:solidFill>
                   <a:srgbClr val="000000"/>
@@ -2484,7 +2484,7 @@
                 <a:spcPct val="100000"/>
               </a:lnSpc>
             </a:pPr>
-            <a:fld id="{5DE5BC62-066D-4D6A-9707-8157BC61E041}" type="slidenum">
+            <a:fld id="{0804B9AA-5A42-41F4-95A8-8FB763B7AECC}" type="slidenum">
               <a:rPr lang="ru-RU" sz="1400" b="0" u="none" strike="noStrike">
                 <a:solidFill>
                   <a:srgbClr val="000000"/>
@@ -2536,7 +2536,7 @@
                 <a:spcPct val="100000"/>
               </a:lnSpc>
             </a:pPr>
-            <a:fld id="{73966D71-01EE-4D58-ABC5-ACA61556389C}" type="slidenum">
+            <a:fld id="{6FE8742C-036C-4694-A104-071FD1CF64FD}" type="slidenum">
               <a:rPr lang="ru-RU" sz="1400" b="0" u="none" strike="noStrike">
                 <a:solidFill>
                   <a:srgbClr val="000000"/>
@@ -2588,7 +2588,7 @@
                 <a:spcPct val="100000"/>
               </a:lnSpc>
             </a:pPr>
-            <a:fld id="{CF90EBD5-F5AD-4797-892D-95AF6C052500}" type="slidenum">
+            <a:fld id="{EA41EF0A-30F6-4EAF-83DC-1A4F9BEC76EC}" type="slidenum">
               <a:rPr lang="ru-RU" sz="1400" b="0" u="none" strike="noStrike">
                 <a:solidFill>
                   <a:srgbClr val="000000"/>
@@ -2640,7 +2640,7 @@
                 <a:spcPct val="100000"/>
               </a:lnSpc>
             </a:pPr>
-            <a:fld id="{E114E317-C183-4DDB-80DF-3056E2E89679}" type="slidenum">
+            <a:fld id="{CABD3072-8F7F-47BF-BD87-AD5013BB031B}" type="slidenum">
               <a:rPr lang="ru-RU" sz="1400" b="0" u="none" strike="noStrike">
                 <a:solidFill>
                   <a:srgbClr val="000000"/>
@@ -2779,7 +2779,7 @@
                 <a:spcPct val="100000"/>
               </a:lnSpc>
             </a:pPr>
-            <a:fld id="{2DC655CB-7D30-4C9A-AA75-E7077FE1DC25}" type="slidenum">
+            <a:fld id="{FBAC94E0-F3E7-4960-B05B-92051102BAC4}" type="slidenum">
               <a:rPr lang="ru-RU" sz="1400" b="0" u="none" strike="noStrike">
                 <a:solidFill>
                   <a:srgbClr val="000000"/>
@@ -2831,7 +2831,7 @@
                 <a:spcPct val="100000"/>
               </a:lnSpc>
             </a:pPr>
-            <a:fld id="{B8DEF780-C989-49EB-8732-73C2E0E3C930}" type="slidenum">
+            <a:fld id="{C63B2937-146E-4F59-879B-EC9CF1097A8D}" type="slidenum">
               <a:rPr lang="ru-RU" sz="1400" b="0" u="none" strike="noStrike">
                 <a:solidFill>
                   <a:srgbClr val="000000"/>
@@ -2883,7 +2883,7 @@
                 <a:spcPct val="100000"/>
               </a:lnSpc>
             </a:pPr>
-            <a:fld id="{E0E7E6DE-F796-4C1C-84C1-402C7C6932F8}" type="slidenum">
+            <a:fld id="{76A00D48-38A5-415F-B5DE-3055E1D13CEB}" type="slidenum">
               <a:rPr lang="ru-RU" sz="1400" b="0" u="none" strike="noStrike">
                 <a:solidFill>
                   <a:srgbClr val="000000"/>
@@ -2935,7 +2935,7 @@
                 <a:spcPct val="100000"/>
               </a:lnSpc>
             </a:pPr>
-            <a:fld id="{897AD5BB-4D72-40CF-A350-615455E043C8}" type="slidenum">
+            <a:fld id="{A26BCB0D-6E25-43AA-B8DE-B3C1BFEB33A1}" type="slidenum">
               <a:rPr lang="ru-RU" sz="1400" b="0" u="none" strike="noStrike">
                 <a:solidFill>
                   <a:srgbClr val="000000"/>
@@ -2987,7 +2987,7 @@
                 <a:spcPct val="100000"/>
               </a:lnSpc>
             </a:pPr>
-            <a:fld id="{C17B8C6A-8ADA-432A-B640-8F308DCC0F1F}" type="slidenum">
+            <a:fld id="{1C452A21-675F-4B42-AA4B-089EB4424846}" type="slidenum">
               <a:rPr lang="ru-RU" sz="1400" b="0" u="none" strike="noStrike">
                 <a:solidFill>
                   <a:srgbClr val="000000"/>
@@ -3039,7 +3039,7 @@
                 <a:spcPct val="100000"/>
               </a:lnSpc>
             </a:pPr>
-            <a:fld id="{7CF975EA-E585-4603-8FB6-25549E1D746C}" type="slidenum">
+            <a:fld id="{6373F326-8330-432C-93D0-AEC89A652D4B}" type="slidenum">
               <a:rPr lang="ru-RU" sz="1400" b="0" u="none" strike="noStrike">
                 <a:solidFill>
                   <a:srgbClr val="000000"/>
@@ -3178,7 +3178,7 @@
                 <a:spcPct val="100000"/>
               </a:lnSpc>
             </a:pPr>
-            <a:fld id="{713F75D4-840D-43F5-A325-12B9F2EABA61}" type="slidenum">
+            <a:fld id="{91D9F1BD-D186-4DFE-92B0-A7027CC33FB4}" type="slidenum">
               <a:rPr lang="ru-RU" sz="1400" b="0" u="none" strike="noStrike">
                 <a:solidFill>
                   <a:srgbClr val="000000"/>
@@ -3230,7 +3230,7 @@
                 <a:spcPct val="100000"/>
               </a:lnSpc>
             </a:pPr>
-            <a:fld id="{A2D5D3C5-2706-4DDD-B806-543089290817}" type="slidenum">
+            <a:fld id="{47AA8AA7-4274-43A3-9D47-EE4436CB6510}" type="slidenum">
               <a:rPr lang="ru-RU" sz="1400" b="0" u="none" strike="noStrike">
                 <a:solidFill>
                   <a:srgbClr val="000000"/>
@@ -3282,7 +3282,7 @@
                 <a:spcPct val="100000"/>
               </a:lnSpc>
             </a:pPr>
-            <a:fld id="{0BCC3915-4045-49D6-95C6-F97B1C9FA7C5}" type="slidenum">
+            <a:fld id="{09FBCC4A-74DC-48F9-8166-15A1ABDF416E}" type="slidenum">
               <a:rPr lang="ru-RU" sz="1400" b="0" u="none" strike="noStrike">
                 <a:solidFill>
                   <a:srgbClr val="000000"/>
@@ -3334,7 +3334,7 @@
                 <a:spcPct val="100000"/>
               </a:lnSpc>
             </a:pPr>
-            <a:fld id="{843C74CF-2F0A-42F5-B3AE-6BCFC5FCC6CE}" type="slidenum">
+            <a:fld id="{A587FEA5-2D1C-469D-946D-CFB45FC99D3B}" type="slidenum">
               <a:rPr lang="ru-RU" sz="1400" b="0" u="none" strike="noStrike">
                 <a:solidFill>
                   <a:srgbClr val="000000"/>
@@ -3386,7 +3386,7 @@
                 <a:spcPct val="100000"/>
               </a:lnSpc>
             </a:pPr>
-            <a:fld id="{43842706-C32F-40CE-9814-6981F8FE98E1}" type="slidenum">
+            <a:fld id="{B90361F9-79FA-4F3B-A86B-B1E73627CBE6}" type="slidenum">
               <a:rPr lang="ru-RU" sz="1400" b="0" u="none" strike="noStrike">
                 <a:solidFill>
                   <a:srgbClr val="000000"/>
@@ -3438,7 +3438,7 @@
                 <a:spcPct val="100000"/>
               </a:lnSpc>
             </a:pPr>
-            <a:fld id="{523F3BD9-FBA1-41BD-809F-5FEAC05DC95E}" type="slidenum">
+            <a:fld id="{9A29F4EB-8346-49BB-B262-76F75CB9BB39}" type="slidenum">
               <a:rPr lang="ru-RU" sz="1400" b="0" u="none" strike="noStrike">
                 <a:solidFill>
                   <a:srgbClr val="000000"/>
@@ -3582,7 +3582,7 @@
         <p:txBody>
           <a:bodyPr/>
           <a:p>
-            <a:fld id="{CD4ADC51-5262-41ED-9FBD-E474D43D97F8}" type="slidenum">
+            <a:fld id="{F881A154-ABF7-4778-B435-D6877C28822E}" type="slidenum">
               <a:t>&lt;#&gt;</a:t>
             </a:fld>
           </a:p>
@@ -3665,7 +3665,7 @@
         <p:txBody>
           <a:bodyPr/>
           <a:p>
-            <a:fld id="{86C70993-4277-4BC6-8134-4CC1E1473216}" type="slidenum">
+            <a:fld id="{FDCE09D5-9E24-4434-9598-A5E367B067A7}" type="slidenum">
               <a:t>&lt;#&gt;</a:t>
             </a:fld>
           </a:p>
@@ -3862,7 +3862,7 @@
                 <a:tab pos="0" algn="l"/>
               </a:tabLst>
             </a:pPr>
-            <a:fld id="{D1D8563C-4EC4-41B4-90E4-9B9A84FCFA1C}" type="slidenum">
+            <a:fld id="{093788A7-9378-4FF8-BB7E-D148E18310DA}" type="slidenum">
               <a:rPr lang="ru-RU" sz="1200" b="0" u="none" strike="noStrike">
                 <a:solidFill>
                   <a:srgbClr val="8B8B8B"/>
@@ -4146,7 +4146,7 @@
                 <a:tab pos="0" algn="l"/>
               </a:tabLst>
             </a:pPr>
-            <a:fld id="{6B075AF6-457C-4142-BB17-9251CB90F219}" type="slidenum">
+            <a:fld id="{2AFD13BF-71E6-49A1-B235-0497BB84C56C}" type="slidenum">
               <a:rPr lang="ru-RU" sz="1200" b="0" u="none" strike="noStrike">
                 <a:solidFill>
                   <a:srgbClr val="8B8B8B"/>

</xml_diff>